<commit_message>
Finalize README and presentation
</commit_message>
<xml_diff>
--- a/SME-EnergyIQ_Final_Hackathon_Presentation_V2.pptx
+++ b/SME-EnergyIQ_Final_Hackathon_Presentation_V2.pptx
@@ -8045,7 +8045,7 @@
           <a:solidFill>
             <a:srgbClr val="FFFFFF"/>
           </a:solidFill>
-          <a:ln w="12700">
+          <a:ln w="19050">
             <a:solidFill>
               <a:srgbClr val="E2E8F0"/>
             </a:solidFill>
@@ -8076,47 +8076,6 @@
                 </a:solidFill>
               </a:defRPr>
             </a:pPr>
-            <a:r>
-              <a:t>STAGE 1: ASSETS &amp; SENSORS</a:t>
-            </a:r>
-          </a:p>
-          <a:p>
-            <a:pPr>
-              <a:defRPr sz="1200" b="1">
-                <a:solidFill>
-                  <a:srgbClr val="0F172A"/>
-                </a:solidFill>
-              </a:defRPr>
-            </a:pPr>
-            <a:r>
-              <a:t>Physical Plant Layer</a:t>
-            </a:r>
-          </a:p>
-          <a:p>
-            <a:br/>
-            <a:r>
-              <a:t>• 4 Core Factory Assets:</a:t>
-            </a:r>
-            <a:br/>
-            <a:r>
-              <a:t>  Ring Spindles, Compressor,</a:t>
-            </a:r>
-            <a:br/>
-            <a:r>
-              <a:t>  Dyeing Pump, Chiller.</a:t>
-            </a:r>
-            <a:br/>
-            <a:r>
-              <a:t>• Non-invasive split-core CTs</a:t>
-            </a:r>
-            <a:br/>
-            <a:r>
-              <a:t>• 4-20mA vibration probes</a:t>
-            </a:r>
-            <a:br/>
-            <a:r>
-              <a:t>• PT100 RTD temperature sensors</a:t>
-            </a:r>
           </a:p>
         </p:txBody>
       </p:sp>
@@ -8137,7 +8096,7 @@
           <a:solidFill>
             <a:srgbClr val="FFFFFF"/>
           </a:solidFill>
-          <a:ln w="12700">
+          <a:ln w="19050">
             <a:solidFill>
               <a:srgbClr val="E2E8F0"/>
             </a:solidFill>
@@ -8168,43 +8127,6 @@
                 </a:solidFill>
               </a:defRPr>
             </a:pPr>
-            <a:r>
-              <a:t>STAGE 2: EDGE GATEWAY</a:t>
-            </a:r>
-          </a:p>
-          <a:p>
-            <a:pPr>
-              <a:defRPr sz="1200" b="1">
-                <a:solidFill>
-                  <a:srgbClr val="0F172A"/>
-                </a:solidFill>
-              </a:defRPr>
-            </a:pPr>
-            <a:r>
-              <a:t>Standard Ingestion</a:t>
-            </a:r>
-          </a:p>
-          <a:p>
-            <a:br/>
-            <a:r>
-              <a:t>• Industrial DIN-Rail Gateway</a:t>
-            </a:r>
-            <a:br/>
-            <a:r>
-              <a:t>• Protocols: Modbus RTU / MQTT</a:t>
-            </a:r>
-            <a:br/>
-            <a:r>
-              <a:t>• 15-Minute interval sub-metering</a:t>
-            </a:r>
-            <a:br/>
-            <a:r>
-              <a:t>• Local data buffering (survives network disconnects)</a:t>
-            </a:r>
-            <a:br/>
-            <a:r>
-              <a:t>• Zero machine replacement</a:t>
-            </a:r>
           </a:p>
         </p:txBody>
       </p:sp>
@@ -8225,7 +8147,7 @@
           <a:solidFill>
             <a:srgbClr val="FFFFFF"/>
           </a:solidFill>
-          <a:ln w="12700">
+          <a:ln w="19050">
             <a:solidFill>
               <a:srgbClr val="E2E8F0"/>
             </a:solidFill>
@@ -8256,43 +8178,6 @@
                 </a:solidFill>
               </a:defRPr>
             </a:pPr>
-            <a:r>
-              <a:t>STAGE 3: CORE ANALYTICS</a:t>
-            </a:r>
-          </a:p>
-          <a:p>
-            <a:pPr>
-              <a:defRPr sz="1200" b="1">
-                <a:solidFill>
-                  <a:srgbClr val="0F172A"/>
-                </a:solidFill>
-              </a:defRPr>
-            </a:pPr>
-            <a:r>
-              <a:t>Intelligence Engine</a:t>
-            </a:r>
-          </a:p>
-          <a:p>
-            <a:br/>
-            <a:r>
-              <a:t>• Data Quality &amp; Plausibility Validation</a:t>
-            </a:r>
-            <a:br/>
-            <a:r>
-              <a:t>• Unsupervised Isolation Forest</a:t>
-            </a:r>
-            <a:br/>
-            <a:r>
-              <a:t>• ISO 10816-3 Vibration Severity</a:t>
-            </a:r>
-            <a:br/>
-            <a:r>
-              <a:t>• 24-Hour PuLP MILP Optimizer</a:t>
-            </a:r>
-            <a:br/>
-            <a:r>
-              <a:t>• Scope 2 GHG Carbon Model</a:t>
-            </a:r>
           </a:p>
         </p:txBody>
       </p:sp>
@@ -8313,7 +8198,7 @@
           <a:solidFill>
             <a:srgbClr val="FFFFFF"/>
           </a:solidFill>
-          <a:ln w="12700">
+          <a:ln w="19050">
             <a:solidFill>
               <a:srgbClr val="E2E8F0"/>
             </a:solidFill>
@@ -8344,43 +8229,6 @@
                 </a:solidFill>
               </a:defRPr>
             </a:pPr>
-            <a:r>
-              <a:t>STAGE 4: PLANT DISPATCH</a:t>
-            </a:r>
-          </a:p>
-          <a:p>
-            <a:pPr>
-              <a:defRPr sz="1200" b="1">
-                <a:solidFill>
-                  <a:srgbClr val="0F172A"/>
-                </a:solidFill>
-              </a:defRPr>
-            </a:pPr>
-            <a:r>
-              <a:t>Operator Decision</a:t>
-            </a:r>
-          </a:p>
-          <a:p>
-            <a:br/>
-            <a:r>
-              <a:t>• Executive Energy Dashboard</a:t>
-            </a:r>
-            <a:br/>
-            <a:r>
-              <a:t>• 4-Tier Explainable Alerts</a:t>
-            </a:r>
-            <a:br/>
-            <a:r>
-              <a:t>• Machine Health Scores (0-100)</a:t>
-            </a:r>
-            <a:br/>
-            <a:r>
-              <a:t>• Time-of-Day Shift Schedule</a:t>
-            </a:r>
-            <a:br/>
-            <a:r>
-              <a:t>• Daily Scope 2 ESG Report</a:t>
-            </a:r>
           </a:p>
         </p:txBody>
       </p:sp>
@@ -8628,6 +8476,768 @@
             </a:pPr>
             <a:r>
               <a:t>05 / 12</a:t>
+            </a:r>
+          </a:p>
+        </p:txBody>
+      </p:sp>
+      <p:sp>
+        <p:nvSpPr>
+          <p:cNvPr id="14" name="TextBox 13"/>
+          <p:cNvSpPr txBox="1"/>
+          <p:nvPr/>
+        </p:nvSpPr>
+        <p:spPr>
+          <a:xfrm>
+            <a:off x="822960" y="1600200"/>
+            <a:ext cx="2359152" cy="2743200"/>
+          </a:xfrm>
+          <a:prstGeom prst="rect">
+            <a:avLst/>
+          </a:prstGeom>
+          <a:noFill/>
+        </p:spPr>
+        <p:txBody>
+          <a:bodyPr wrap="square" anchor="t" lIns="0" rIns="0" tIns="0" bIns="0">
+            <a:spAutoFit/>
+          </a:bodyPr>
+          <a:lstStyle/>
+          <a:p>
+            <a:pPr algn="ctr"/>
+            <a:r>
+              <a:rPr sz="850" b="1">
+                <a:solidFill>
+                  <a:srgbClr val="2563EB"/>
+                </a:solidFill>
+                <a:latin typeface="Segoe UI"/>
+              </a:rPr>
+              <a:t>STAGE 1: ASSETS &amp; SENSORS</a:t>
+            </a:r>
+          </a:p>
+          <a:p>
+            <a:pPr algn="ctr">
+              <a:spcAft>
+                <a:spcPts val="600"/>
+              </a:spcAft>
+            </a:pPr>
+            <a:r>
+              <a:rPr sz="1100" b="1">
+                <a:solidFill>
+                  <a:srgbClr val="0F172A"/>
+                </a:solidFill>
+                <a:latin typeface="Segoe UI"/>
+              </a:rPr>
+              <a:t>Physical Plant Layer</a:t>
+            </a:r>
+          </a:p>
+          <a:p>
+            <a:pPr>
+              <a:spcAft>
+                <a:spcPts val="200"/>
+              </a:spcAft>
+            </a:pPr>
+            <a:r>
+              <a:rPr sz="900" b="1">
+                <a:solidFill>
+                  <a:srgbClr val="0F172A"/>
+                </a:solidFill>
+                <a:latin typeface="Segoe UI"/>
+              </a:rPr>
+              <a:t>Factory Machines</a:t>
+            </a:r>
+          </a:p>
+          <a:p>
+            <a:r>
+              <a:rPr sz="800" b="1">
+                <a:solidFill>
+                  <a:srgbClr val="2563EB"/>
+                </a:solidFill>
+                <a:latin typeface="Segoe UI"/>
+              </a:rPr>
+              <a:t>• </a:t>
+            </a:r>
+            <a:r>
+              <a:rPr sz="800" b="1">
+                <a:solidFill>
+                  <a:srgbClr val="0F172A"/>
+                </a:solidFill>
+                <a:latin typeface="Segoe UI"/>
+              </a:rPr>
+              <a:t>MOTOR_01: </a:t>
+            </a:r>
+            <a:r>
+              <a:rPr sz="780">
+                <a:solidFill>
+                  <a:srgbClr val="334155"/>
+                </a:solidFill>
+                <a:latin typeface="Segoe UI"/>
+              </a:rPr>
+              <a:t>Ring Spinning Motor</a:t>
+            </a:r>
+          </a:p>
+          <a:p>
+            <a:r>
+              <a:rPr sz="800" b="1">
+                <a:solidFill>
+                  <a:srgbClr val="2563EB"/>
+                </a:solidFill>
+                <a:latin typeface="Segoe UI"/>
+              </a:rPr>
+              <a:t>• </a:t>
+            </a:r>
+            <a:r>
+              <a:rPr sz="800" b="1">
+                <a:solidFill>
+                  <a:srgbClr val="0F172A"/>
+                </a:solidFill>
+                <a:latin typeface="Segoe UI"/>
+              </a:rPr>
+              <a:t>COMPRESSOR_01: </a:t>
+            </a:r>
+            <a:r>
+              <a:rPr sz="780">
+                <a:solidFill>
+                  <a:srgbClr val="334155"/>
+                </a:solidFill>
+                <a:latin typeface="Segoe UI"/>
+              </a:rPr>
+              <a:t>Air Compressor</a:t>
+            </a:r>
+          </a:p>
+          <a:p>
+            <a:r>
+              <a:rPr sz="800" b="1">
+                <a:solidFill>
+                  <a:srgbClr val="2563EB"/>
+                </a:solidFill>
+                <a:latin typeface="Segoe UI"/>
+              </a:rPr>
+              <a:t>• </a:t>
+            </a:r>
+            <a:r>
+              <a:rPr sz="800" b="1">
+                <a:solidFill>
+                  <a:srgbClr val="0F172A"/>
+                </a:solidFill>
+                <a:latin typeface="Segoe UI"/>
+              </a:rPr>
+              <a:t>PUMP_01: </a:t>
+            </a:r>
+            <a:r>
+              <a:rPr sz="780">
+                <a:solidFill>
+                  <a:srgbClr val="334155"/>
+                </a:solidFill>
+                <a:latin typeface="Segoe UI"/>
+              </a:rPr>
+              <a:t>Dyeing / Process Pump</a:t>
+            </a:r>
+          </a:p>
+          <a:p>
+            <a:r>
+              <a:rPr sz="800" b="1">
+                <a:solidFill>
+                  <a:srgbClr val="2563EB"/>
+                </a:solidFill>
+                <a:latin typeface="Segoe UI"/>
+              </a:rPr>
+              <a:t>• </a:t>
+            </a:r>
+            <a:r>
+              <a:rPr sz="800" b="1">
+                <a:solidFill>
+                  <a:srgbClr val="0F172A"/>
+                </a:solidFill>
+                <a:latin typeface="Segoe UI"/>
+              </a:rPr>
+              <a:t>HVAC_01: </a:t>
+            </a:r>
+            <a:r>
+              <a:rPr sz="780">
+                <a:solidFill>
+                  <a:srgbClr val="334155"/>
+                </a:solidFill>
+                <a:latin typeface="Segoe UI"/>
+              </a:rPr>
+              <a:t>Climate Control</a:t>
+            </a:r>
+          </a:p>
+          <a:p>
+            <a:pPr>
+              <a:spcBef>
+                <a:spcPts val="600"/>
+              </a:spcBef>
+              <a:spcAft>
+                <a:spcPts val="200"/>
+              </a:spcAft>
+            </a:pPr>
+            <a:r>
+              <a:rPr sz="900" b="1">
+                <a:solidFill>
+                  <a:srgbClr val="0F172A"/>
+                </a:solidFill>
+                <a:latin typeface="Segoe UI"/>
+              </a:rPr>
+              <a:t>Telemetry Captured</a:t>
+            </a:r>
+          </a:p>
+          <a:p>
+            <a:r>
+              <a:rPr sz="780">
+                <a:solidFill>
+                  <a:srgbClr val="334155"/>
+                </a:solidFill>
+                <a:latin typeface="Segoe UI"/>
+              </a:rPr>
+              <a:t>Power (kW), Voltage, Energy (kWh),
+Temperature (°C), Vibration (mm/s),
+RPM, Production Status</a:t>
+            </a:r>
+          </a:p>
+        </p:txBody>
+      </p:sp>
+      <p:sp>
+        <p:nvSpPr>
+          <p:cNvPr id="15" name="TextBox 14"/>
+          <p:cNvSpPr txBox="1"/>
+          <p:nvPr/>
+        </p:nvSpPr>
+        <p:spPr>
+          <a:xfrm>
+            <a:off x="3547872" y="1600200"/>
+            <a:ext cx="2359152" cy="2743200"/>
+          </a:xfrm>
+          <a:prstGeom prst="rect">
+            <a:avLst/>
+          </a:prstGeom>
+          <a:noFill/>
+        </p:spPr>
+        <p:txBody>
+          <a:bodyPr wrap="square" anchor="t" lIns="0" rIns="0" tIns="0" bIns="0">
+            <a:spAutoFit/>
+          </a:bodyPr>
+          <a:lstStyle/>
+          <a:p>
+            <a:pPr algn="ctr"/>
+            <a:r>
+              <a:rPr sz="850" b="1">
+                <a:solidFill>
+                  <a:srgbClr val="0284C7"/>
+                </a:solidFill>
+                <a:latin typeface="Segoe UI"/>
+              </a:rPr>
+              <a:t>STAGE 2: EDGE GATEWAY</a:t>
+            </a:r>
+          </a:p>
+          <a:p>
+            <a:pPr algn="ctr">
+              <a:spcAft>
+                <a:spcPts val="600"/>
+              </a:spcAft>
+            </a:pPr>
+            <a:r>
+              <a:rPr sz="1100" b="1">
+                <a:solidFill>
+                  <a:srgbClr val="0F172A"/>
+                </a:solidFill>
+                <a:latin typeface="Segoe UI"/>
+              </a:rPr>
+              <a:t>Standard Ingestion</a:t>
+            </a:r>
+          </a:p>
+          <a:p>
+            <a:r>
+              <a:rPr sz="900" b="1">
+                <a:solidFill>
+                  <a:srgbClr val="0F172A"/>
+                </a:solidFill>
+                <a:latin typeface="Segoe UI"/>
+              </a:rPr>
+              <a:t>Sensors / Energy Meters</a:t>
+            </a:r>
+          </a:p>
+          <a:p>
+            <a:r>
+              <a:rPr sz="780">
+                <a:solidFill>
+                  <a:srgbClr val="334155"/>
+                </a:solidFill>
+                <a:latin typeface="Segoe UI"/>
+              </a:rPr>
+              <a:t>Split-core CTs &amp; digital power meters</a:t>
+            </a:r>
+          </a:p>
+          <a:p>
+            <a:pPr algn="ctr"/>
+            <a:r>
+              <a:rPr sz="950" b="1">
+                <a:solidFill>
+                  <a:srgbClr val="0284C7"/>
+                </a:solidFill>
+                <a:latin typeface="Segoe UI"/>
+              </a:rPr>
+              <a:t>↓</a:t>
+            </a:r>
+          </a:p>
+          <a:p>
+            <a:r>
+              <a:rPr sz="900" b="1">
+                <a:solidFill>
+                  <a:srgbClr val="0F172A"/>
+                </a:solidFill>
+                <a:latin typeface="Segoe UI"/>
+              </a:rPr>
+              <a:t>Data Acquisition</a:t>
+            </a:r>
+          </a:p>
+          <a:p>
+            <a:r>
+              <a:rPr sz="780">
+                <a:solidFill>
+                  <a:srgbClr val="334155"/>
+                </a:solidFill>
+                <a:latin typeface="Segoe UI"/>
+              </a:rPr>
+              <a:t>Sub-metering @ 15-min intervals</a:t>
+            </a:r>
+          </a:p>
+          <a:p>
+            <a:pPr algn="ctr"/>
+            <a:r>
+              <a:rPr sz="950" b="1">
+                <a:solidFill>
+                  <a:srgbClr val="0284C7"/>
+                </a:solidFill>
+                <a:latin typeface="Segoe UI"/>
+              </a:rPr>
+              <a:t>↓</a:t>
+            </a:r>
+          </a:p>
+          <a:p>
+            <a:r>
+              <a:rPr sz="900" b="1">
+                <a:solidFill>
+                  <a:srgbClr val="0F172A"/>
+                </a:solidFill>
+                <a:latin typeface="Segoe UI"/>
+              </a:rPr>
+              <a:t>Edge Gateway</a:t>
+            </a:r>
+          </a:p>
+          <a:p>
+            <a:r>
+              <a:rPr sz="780">
+                <a:solidFill>
+                  <a:srgbClr val="334155"/>
+                </a:solidFill>
+                <a:latin typeface="Segoe UI"/>
+              </a:rPr>
+              <a:t>Local buffering (fault-tolerant buffer)</a:t>
+            </a:r>
+          </a:p>
+          <a:p>
+            <a:pPr>
+              <a:spcBef>
+                <a:spcPts val="600"/>
+              </a:spcBef>
+            </a:pPr>
+            <a:r>
+              <a:rPr sz="850" b="1">
+                <a:solidFill>
+                  <a:srgbClr val="0F172A"/>
+                </a:solidFill>
+                <a:latin typeface="Segoe UI"/>
+              </a:rPr>
+              <a:t>Industrial Communication:</a:t>
+            </a:r>
+          </a:p>
+          <a:p>
+            <a:r>
+              <a:rPr sz="780" b="1">
+                <a:solidFill>
+                  <a:srgbClr val="0284C7"/>
+                </a:solidFill>
+                <a:latin typeface="Segoe UI"/>
+              </a:rPr>
+              <a:t>Modbus RTU / MQTT (Hardware-Agnostic)</a:t>
+            </a:r>
+          </a:p>
+        </p:txBody>
+      </p:sp>
+      <p:sp>
+        <p:nvSpPr>
+          <p:cNvPr id="16" name="TextBox 15"/>
+          <p:cNvSpPr txBox="1"/>
+          <p:nvPr/>
+        </p:nvSpPr>
+        <p:spPr>
+          <a:xfrm>
+            <a:off x="6272784" y="1600200"/>
+            <a:ext cx="2359152" cy="2743200"/>
+          </a:xfrm>
+          <a:prstGeom prst="rect">
+            <a:avLst/>
+          </a:prstGeom>
+          <a:noFill/>
+        </p:spPr>
+        <p:txBody>
+          <a:bodyPr wrap="square" anchor="t" lIns="0" rIns="0" tIns="0" bIns="0">
+            <a:spAutoFit/>
+          </a:bodyPr>
+          <a:lstStyle/>
+          <a:p>
+            <a:pPr algn="ctr"/>
+            <a:r>
+              <a:rPr sz="850" b="1">
+                <a:solidFill>
+                  <a:srgbClr val="008A00"/>
+                </a:solidFill>
+                <a:latin typeface="Segoe UI"/>
+              </a:rPr>
+              <a:t>STAGE 3: CORE ANALYTICS</a:t>
+            </a:r>
+          </a:p>
+          <a:p>
+            <a:pPr algn="ctr">
+              <a:spcAft>
+                <a:spcPts val="600"/>
+              </a:spcAft>
+            </a:pPr>
+            <a:r>
+              <a:rPr sz="1100" b="1">
+                <a:solidFill>
+                  <a:srgbClr val="0F172A"/>
+                </a:solidFill>
+                <a:latin typeface="Segoe UI"/>
+              </a:rPr>
+              <a:t>Intelligence Engine</a:t>
+            </a:r>
+          </a:p>
+          <a:p>
+            <a:r>
+              <a:rPr sz="850" b="1">
+                <a:solidFill>
+                  <a:srgbClr val="0F172A"/>
+                </a:solidFill>
+                <a:latin typeface="Segoe UI"/>
+              </a:rPr>
+              <a:t>Data Processing</a:t>
+            </a:r>
+          </a:p>
+          <a:p>
+            <a:r>
+              <a:rPr sz="750">
+                <a:solidFill>
+                  <a:srgbClr val="334155"/>
+                </a:solidFill>
+                <a:latin typeface="Segoe UI"/>
+              </a:rPr>
+              <a:t>Plausibility audit &amp; feature engineering</a:t>
+            </a:r>
+          </a:p>
+          <a:p>
+            <a:pPr algn="ctr"/>
+            <a:r>
+              <a:rPr sz="850" b="1">
+                <a:solidFill>
+                  <a:srgbClr val="008A00"/>
+                </a:solidFill>
+                <a:latin typeface="Segoe UI"/>
+              </a:rPr>
+              <a:t>↓</a:t>
+            </a:r>
+          </a:p>
+          <a:p>
+            <a:r>
+              <a:rPr sz="850" b="1">
+                <a:solidFill>
+                  <a:srgbClr val="0F172A"/>
+                </a:solidFill>
+                <a:latin typeface="Segoe UI"/>
+              </a:rPr>
+              <a:t>AI Anomaly Detection</a:t>
+            </a:r>
+          </a:p>
+          <a:p>
+            <a:r>
+              <a:rPr sz="750">
+                <a:solidFill>
+                  <a:srgbClr val="334155"/>
+                </a:solidFill>
+                <a:latin typeface="Segoe UI"/>
+              </a:rPr>
+              <a:t>Unsupervised Isolation Forest model</a:t>
+            </a:r>
+          </a:p>
+          <a:p>
+            <a:pPr algn="ctr"/>
+            <a:r>
+              <a:rPr sz="850" b="1">
+                <a:solidFill>
+                  <a:srgbClr val="008A00"/>
+                </a:solidFill>
+                <a:latin typeface="Segoe UI"/>
+              </a:rPr>
+              <a:t>↓</a:t>
+            </a:r>
+          </a:p>
+          <a:p>
+            <a:r>
+              <a:rPr sz="850" b="1">
+                <a:solidFill>
+                  <a:srgbClr val="0F172A"/>
+                </a:solidFill>
+                <a:latin typeface="Segoe UI"/>
+              </a:rPr>
+              <a:t>Machine Health</a:t>
+            </a:r>
+          </a:p>
+          <a:p>
+            <a:r>
+              <a:rPr sz="750">
+                <a:solidFill>
+                  <a:srgbClr val="334155"/>
+                </a:solidFill>
+                <a:latin typeface="Segoe UI"/>
+              </a:rPr>
+              <a:t>ISO 10816-3 severity &amp; 0-100 score</a:t>
+            </a:r>
+          </a:p>
+          <a:p>
+            <a:pPr algn="ctr"/>
+            <a:r>
+              <a:rPr sz="850" b="1">
+                <a:solidFill>
+                  <a:srgbClr val="008A00"/>
+                </a:solidFill>
+                <a:latin typeface="Segoe UI"/>
+              </a:rPr>
+              <a:t>↓</a:t>
+            </a:r>
+          </a:p>
+          <a:p>
+            <a:r>
+              <a:rPr sz="850" b="1">
+                <a:solidFill>
+                  <a:srgbClr val="0F172A"/>
+                </a:solidFill>
+                <a:latin typeface="Segoe UI"/>
+              </a:rPr>
+              <a:t>Explainable Diagnostics</a:t>
+            </a:r>
+          </a:p>
+          <a:p>
+            <a:r>
+              <a:rPr sz="750">
+                <a:solidFill>
+                  <a:srgbClr val="334155"/>
+                </a:solidFill>
+                <a:latin typeface="Segoe UI"/>
+              </a:rPr>
+              <a:t>4-tier actionable engineering insights</a:t>
+            </a:r>
+          </a:p>
+        </p:txBody>
+      </p:sp>
+      <p:sp>
+        <p:nvSpPr>
+          <p:cNvPr id="17" name="TextBox 16"/>
+          <p:cNvSpPr txBox="1"/>
+          <p:nvPr/>
+        </p:nvSpPr>
+        <p:spPr>
+          <a:xfrm>
+            <a:off x="8997696" y="1600200"/>
+            <a:ext cx="2359152" cy="2743200"/>
+          </a:xfrm>
+          <a:prstGeom prst="rect">
+            <a:avLst/>
+          </a:prstGeom>
+          <a:noFill/>
+        </p:spPr>
+        <p:txBody>
+          <a:bodyPr wrap="square" anchor="t" lIns="0" rIns="0" tIns="0" bIns="0">
+            <a:spAutoFit/>
+          </a:bodyPr>
+          <a:lstStyle/>
+          <a:p>
+            <a:pPr algn="ctr"/>
+            <a:r>
+              <a:rPr sz="850" b="1">
+                <a:solidFill>
+                  <a:srgbClr val="7C3AED"/>
+                </a:solidFill>
+                <a:latin typeface="Segoe UI"/>
+              </a:rPr>
+              <a:t>STAGE 4: PLANT DISPATCH</a:t>
+            </a:r>
+          </a:p>
+          <a:p>
+            <a:pPr algn="ctr">
+              <a:spcAft>
+                <a:spcPts val="400"/>
+              </a:spcAft>
+            </a:pPr>
+            <a:r>
+              <a:rPr sz="1100" b="1">
+                <a:solidFill>
+                  <a:srgbClr val="0F172A"/>
+                </a:solidFill>
+                <a:latin typeface="Segoe UI"/>
+              </a:rPr>
+              <a:t>Operator Decision</a:t>
+            </a:r>
+          </a:p>
+          <a:p>
+            <a:r>
+              <a:rPr sz="850" b="1">
+                <a:solidFill>
+                  <a:srgbClr val="0F172A"/>
+                </a:solidFill>
+                <a:latin typeface="Segoe UI"/>
+              </a:rPr>
+              <a:t>Production Optimization</a:t>
+            </a:r>
+          </a:p>
+          <a:p>
+            <a:pPr>
+              <a:spcAft>
+                <a:spcPts val="400"/>
+              </a:spcAft>
+            </a:pPr>
+            <a:r>
+              <a:rPr sz="780" b="1">
+                <a:solidFill>
+                  <a:srgbClr val="7C3AED"/>
+                </a:solidFill>
+                <a:latin typeface="Segoe UI"/>
+              </a:rPr>
+              <a:t>MILP Optimizer (PuLP 24h Model)</a:t>
+            </a:r>
+          </a:p>
+          <a:p>
+            <a:r>
+              <a:rPr sz="800" b="1">
+                <a:solidFill>
+                  <a:srgbClr val="0F172A"/>
+                </a:solidFill>
+                <a:latin typeface="Segoe UI"/>
+              </a:rPr>
+              <a:t>Inputs:</a:t>
+            </a:r>
+          </a:p>
+          <a:p>
+            <a:r>
+              <a:rPr sz="720">
+                <a:solidFill>
+                  <a:srgbClr val="334155"/>
+                </a:solidFill>
+                <a:latin typeface="Segoe UI"/>
+              </a:rPr>
+              <a:t>• Time-of-Day Tariff (Peak ₹10/kWh)</a:t>
+            </a:r>
+          </a:p>
+          <a:p>
+            <a:r>
+              <a:rPr sz="720">
+                <a:solidFill>
+                  <a:srgbClr val="334155"/>
+                </a:solidFill>
+                <a:latin typeface="Segoe UI"/>
+              </a:rPr>
+              <a:t>• Machine Health Deratings</a:t>
+            </a:r>
+          </a:p>
+          <a:p>
+            <a:r>
+              <a:rPr sz="720">
+                <a:solidFill>
+                  <a:srgbClr val="334155"/>
+                </a:solidFill>
+                <a:latin typeface="Segoe UI"/>
+              </a:rPr>
+              <a:t>• Production Constraints (4,500 kg)</a:t>
+            </a:r>
+          </a:p>
+          <a:p>
+            <a:r>
+              <a:rPr sz="720">
+                <a:solidFill>
+                  <a:srgbClr val="334155"/>
+                </a:solidFill>
+                <a:latin typeface="Segoe UI"/>
+              </a:rPr>
+              <a:t>• Process / Batch Constraints</a:t>
+            </a:r>
+          </a:p>
+          <a:p>
+            <a:pPr>
+              <a:spcBef>
+                <a:spcPts val="300"/>
+              </a:spcBef>
+            </a:pPr>
+            <a:r>
+              <a:rPr sz="800" b="1">
+                <a:solidFill>
+                  <a:srgbClr val="0F172A"/>
+                </a:solidFill>
+                <a:latin typeface="Segoe UI"/>
+              </a:rPr>
+              <a:t>Outputs:</a:t>
+            </a:r>
+          </a:p>
+          <a:p>
+            <a:r>
+              <a:rPr sz="720">
+                <a:solidFill>
+                  <a:srgbClr val="334155"/>
+                </a:solidFill>
+                <a:latin typeface="Segoe UI"/>
+              </a:rPr>
+              <a:t>• Optimized Schedule (Shifted load)</a:t>
+            </a:r>
+          </a:p>
+          <a:p>
+            <a:r>
+              <a:rPr sz="720">
+                <a:solidFill>
+                  <a:srgbClr val="334155"/>
+                </a:solidFill>
+                <a:latin typeface="Segoe UI"/>
+              </a:rPr>
+              <a:t>• Energy Impact (-13.4 kWh/d)</a:t>
+            </a:r>
+          </a:p>
+          <a:p>
+            <a:r>
+              <a:rPr sz="720">
+                <a:solidFill>
+                  <a:srgbClr val="334155"/>
+                </a:solidFill>
+                <a:latin typeface="Segoe UI"/>
+              </a:rPr>
+              <a:t>• Cost Impact (-4.78%, ₹1,128/d)</a:t>
+            </a:r>
+          </a:p>
+          <a:p>
+            <a:r>
+              <a:rPr sz="720">
+                <a:solidFill>
+                  <a:srgbClr val="334155"/>
+                </a:solidFill>
+                <a:latin typeface="Segoe UI"/>
+              </a:rPr>
+              <a:t>• Peak Demand Impact (-8.08%)</a:t>
+            </a:r>
+          </a:p>
+          <a:p>
+            <a:r>
+              <a:rPr sz="720">
+                <a:solidFill>
+                  <a:srgbClr val="334155"/>
+                </a:solidFill>
+                <a:latin typeface="Segoe UI"/>
+              </a:rPr>
+              <a:t>• SEC / Carbon Impact (-11 kg CO2e)</a:t>
             </a:r>
           </a:p>
         </p:txBody>

</xml_diff>